<commit_message>
knf: 08_paste_pack(무료 계정용) 추가, 덱 d2p3·d2p5·d3p3 재빌드
Co-Authored-By: Claude Opus 5.5 <noreply@anthropic.com>
</commit_message>
<xml_diff>
--- a/knf/decks/d2p3.pptx
+++ b/knf/decks/d2p3.pptx
@@ -16,6 +16,7 @@
     <p:sldId id="264" r:id="rId15"/>
     <p:sldId id="265" r:id="rId16"/>
     <p:sldId id="266" r:id="rId17"/>
+    <p:sldId id="267" r:id="rId18"/>
   </p:sldIdLst>
   <p:sldSz cx="18288000" cy="10287000" type="screen4x3"/>
   <p:notesSz cx="6858000" cy="9144000"/>
@@ -4651,6 +4652,1067 @@
 </file>
 
 <file path=ppt/slides/slide11.xml><?xml version="1.0" encoding="utf-8"?>
+<p:sld xmlns:a="http://schemas.openxmlformats.org/drawingml/2006/main" xmlns:p="http://schemas.openxmlformats.org/presentationml/2006/main" xmlns:r="http://schemas.openxmlformats.org/officeDocument/2006/relationships">
+  <p:cSld>
+    <p:spTree>
+      <p:nvGrpSpPr>
+        <p:cNvPr id="1" name=""/>
+        <p:cNvGrpSpPr/>
+        <p:nvPr/>
+      </p:nvGrpSpPr>
+      <p:grpSpPr/>
+      <p:sp>
+        <p:nvSpPr>
+          <p:cNvPr id="2" name="Oval 1"/>
+          <p:cNvSpPr/>
+          <p:nvPr/>
+        </p:nvSpPr>
+        <p:spPr>
+          <a:xfrm>
+            <a:off x="15811500" y="8382000"/>
+            <a:ext cx="4953000" cy="4953000"/>
+          </a:xfrm>
+          <a:prstGeom prst="ellipse">
+            <a:avLst/>
+          </a:prstGeom>
+          <a:solidFill>
+            <a:srgbClr val="F2F8F8"/>
+          </a:solidFill>
+          <a:ln>
+            <a:noFill/>
+          </a:ln>
+          <a:effectLst/>
+        </p:spPr>
+        <p:txBody>
+          <a:bodyPr rtlCol="0" anchor="ctr" wrap="square"/>
+          <a:lstStyle/>
+          <a:p>
+            <a:pPr algn="ctr"/>
+          </a:p>
+        </p:txBody>
+      </p:sp>
+      <p:sp>
+        <p:nvSpPr>
+          <p:cNvPr id="3" name="Oval 2"/>
+          <p:cNvSpPr/>
+          <p:nvPr/>
+        </p:nvSpPr>
+        <p:spPr>
+          <a:xfrm>
+            <a:off x="16859250" y="9429750"/>
+            <a:ext cx="2857500" cy="2857500"/>
+          </a:xfrm>
+          <a:prstGeom prst="ellipse">
+            <a:avLst/>
+          </a:prstGeom>
+          <a:solidFill>
+            <a:srgbClr val="FFFFFF"/>
+          </a:solidFill>
+          <a:ln>
+            <a:noFill/>
+          </a:ln>
+          <a:effectLst/>
+        </p:spPr>
+        <p:txBody>
+          <a:bodyPr rtlCol="0" anchor="ctr" wrap="square"/>
+          <a:lstStyle/>
+          <a:p>
+            <a:pPr algn="ctr"/>
+          </a:p>
+        </p:txBody>
+      </p:sp>
+      <p:sp>
+        <p:nvSpPr>
+          <p:cNvPr id="4" name="Oval 3"/>
+          <p:cNvSpPr/>
+          <p:nvPr/>
+        </p:nvSpPr>
+        <p:spPr>
+          <a:xfrm>
+            <a:off x="-1428750" y="1428750"/>
+            <a:ext cx="2857500" cy="2857500"/>
+          </a:xfrm>
+          <a:prstGeom prst="ellipse">
+            <a:avLst/>
+          </a:prstGeom>
+          <a:solidFill>
+            <a:srgbClr val="F7F8F9"/>
+          </a:solidFill>
+          <a:ln>
+            <a:noFill/>
+          </a:ln>
+          <a:effectLst/>
+        </p:spPr>
+        <p:txBody>
+          <a:bodyPr rtlCol="0" anchor="ctr" wrap="square"/>
+          <a:lstStyle/>
+          <a:p>
+            <a:pPr algn="ctr"/>
+          </a:p>
+        </p:txBody>
+      </p:sp>
+      <p:sp>
+        <p:nvSpPr>
+          <p:cNvPr id="5" name="TextBox 4"/>
+          <p:cNvSpPr txBox="1"/>
+          <p:nvPr/>
+        </p:nvSpPr>
+        <p:spPr>
+          <a:xfrm>
+            <a:off x="1143000" y="838200"/>
+            <a:ext cx="16002000" cy="342900"/>
+          </a:xfrm>
+          <a:prstGeom prst="rect">
+            <a:avLst/>
+          </a:prstGeom>
+          <a:noFill/>
+        </p:spPr>
+        <p:txBody>
+          <a:bodyPr wrap="square" lIns="0" rIns="0" tIns="0" bIns="0" anchor="t">
+            <a:spAutoFit/>
+          </a:bodyPr>
+          <a:lstStyle/>
+          <a:p>
+            <a:pPr algn="l">
+              <a:lnSpc>
+                <a:spcPct val="100000"/>
+              </a:lnSpc>
+            </a:pPr>
+            <a:r>
+              <a:rPr sz="1950" b="1" spc="160">
+                <a:solidFill>
+                  <a:srgbClr val="0E7C86"/>
+                </a:solidFill>
+                <a:latin typeface="Pretendard"/>
+                <a:ea typeface="Pretendard"/>
+                <a:cs typeface="Pretendard"/>
+              </a:rPr>
+              <a:t>무료 계정이면</a:t>
+            </a:r>
+          </a:p>
+        </p:txBody>
+      </p:sp>
+      <p:sp>
+        <p:nvSpPr>
+          <p:cNvPr id="6" name="TextBox 5"/>
+          <p:cNvSpPr txBox="1"/>
+          <p:nvPr/>
+        </p:nvSpPr>
+        <p:spPr>
+          <a:xfrm>
+            <a:off x="1143000" y="1162050"/>
+            <a:ext cx="16002000" cy="762000"/>
+          </a:xfrm>
+          <a:prstGeom prst="rect">
+            <a:avLst/>
+          </a:prstGeom>
+          <a:noFill/>
+        </p:spPr>
+        <p:txBody>
+          <a:bodyPr wrap="square" lIns="0" rIns="0" tIns="0" bIns="0" anchor="t">
+            <a:spAutoFit/>
+          </a:bodyPr>
+          <a:lstStyle/>
+          <a:p>
+            <a:pPr algn="l">
+              <a:lnSpc>
+                <a:spcPct val="100000"/>
+              </a:lnSpc>
+            </a:pPr>
+            <a:r>
+              <a:rPr sz="5100" b="1">
+                <a:solidFill>
+                  <a:srgbClr val="0E2F4F"/>
+                </a:solidFill>
+                <a:latin typeface="Pretendard"/>
+                <a:ea typeface="Pretendard"/>
+                <a:cs typeface="Pretendard"/>
+              </a:rPr>
+              <a:t>파일 대신 합계표 6행으로도 같은 결과</a:t>
+            </a:r>
+          </a:p>
+        </p:txBody>
+      </p:sp>
+      <p:sp>
+        <p:nvSpPr>
+          <p:cNvPr id="7" name="Rectangle 6"/>
+          <p:cNvSpPr/>
+          <p:nvPr/>
+        </p:nvSpPr>
+        <p:spPr>
+          <a:xfrm>
+            <a:off x="1143000" y="2038350"/>
+            <a:ext cx="16002000" cy="28575"/>
+          </a:xfrm>
+          <a:prstGeom prst="rect">
+            <a:avLst/>
+          </a:prstGeom>
+          <a:solidFill>
+            <a:srgbClr val="0E2F4F"/>
+          </a:solidFill>
+          <a:ln>
+            <a:noFill/>
+          </a:ln>
+          <a:effectLst/>
+        </p:spPr>
+        <p:txBody>
+          <a:bodyPr rtlCol="0" anchor="ctr" wrap="square"/>
+          <a:lstStyle/>
+          <a:p>
+            <a:pPr algn="ctr"/>
+          </a:p>
+        </p:txBody>
+      </p:sp>
+      <p:sp>
+        <p:nvSpPr>
+          <p:cNvPr id="8" name="TextBox 7"/>
+          <p:cNvSpPr txBox="1"/>
+          <p:nvPr/>
+        </p:nvSpPr>
+        <p:spPr>
+          <a:xfrm>
+            <a:off x="1143000" y="2857500"/>
+            <a:ext cx="7372350" cy="533400"/>
+          </a:xfrm>
+          <a:prstGeom prst="rect">
+            <a:avLst/>
+          </a:prstGeom>
+          <a:noFill/>
+        </p:spPr>
+        <p:txBody>
+          <a:bodyPr wrap="square" lIns="0" rIns="0" tIns="0" bIns="0" anchor="t">
+            <a:spAutoFit/>
+          </a:bodyPr>
+          <a:lstStyle/>
+          <a:p>
+            <a:pPr algn="l">
+              <a:lnSpc>
+                <a:spcPct val="110000"/>
+              </a:lnSpc>
+            </a:pPr>
+            <a:r>
+              <a:rPr sz="3150" b="1">
+                <a:solidFill>
+                  <a:srgbClr val="0E2F4F"/>
+                </a:solidFill>
+                <a:latin typeface="Pretendard"/>
+                <a:ea typeface="Pretendard"/>
+                <a:cs typeface="Pretendard"/>
+              </a:rPr>
+              <a:t>파일 분석 가능</a:t>
+            </a:r>
+          </a:p>
+        </p:txBody>
+      </p:sp>
+      <p:sp>
+        <p:nvSpPr>
+          <p:cNvPr id="9" name="TextBox 8"/>
+          <p:cNvSpPr txBox="1"/>
+          <p:nvPr/>
+        </p:nvSpPr>
+        <p:spPr>
+          <a:xfrm>
+            <a:off x="1143000" y="3467100"/>
+            <a:ext cx="7372350" cy="876300"/>
+          </a:xfrm>
+          <a:prstGeom prst="rect">
+            <a:avLst/>
+          </a:prstGeom>
+          <a:noFill/>
+        </p:spPr>
+        <p:txBody>
+          <a:bodyPr wrap="square" lIns="0" rIns="0" tIns="0" bIns="0" anchor="t">
+            <a:spAutoFit/>
+          </a:bodyPr>
+          <a:lstStyle/>
+          <a:p>
+            <a:pPr algn="l">
+              <a:lnSpc>
+                <a:spcPct val="146000"/>
+              </a:lnSpc>
+            </a:pPr>
+            <a:r>
+              <a:rPr sz="2250" b="0">
+                <a:solidFill>
+                  <a:srgbClr val="3D3D3D"/>
+                </a:solidFill>
+                <a:latin typeface="Pretendard"/>
+                <a:ea typeface="Pretendard"/>
+                <a:cs typeface="Pretendard"/>
+              </a:rPr>
+              <a:t>파일을 올려 계산 → Excel 로 대조</a:t>
+            </a:r>
+          </a:p>
+        </p:txBody>
+      </p:sp>
+      <p:sp>
+        <p:nvSpPr>
+          <p:cNvPr id="10" name="Rounded Rectangle 9"/>
+          <p:cNvSpPr/>
+          <p:nvPr/>
+        </p:nvSpPr>
+        <p:spPr>
+          <a:xfrm>
+            <a:off x="1143000" y="4610100"/>
+            <a:ext cx="7372350" cy="2857500"/>
+          </a:xfrm>
+          <a:prstGeom prst="roundRect">
+            <a:avLst>
+              <a:gd name="adj" fmla="val 1666"/>
+            </a:avLst>
+          </a:prstGeom>
+          <a:solidFill>
+            <a:srgbClr val="FAFBFD"/>
+          </a:solidFill>
+          <a:ln w="9525">
+            <a:solidFill>
+              <a:srgbClr val="DCE1E8"/>
+            </a:solidFill>
+          </a:ln>
+          <a:effectLst/>
+        </p:spPr>
+        <p:txBody>
+          <a:bodyPr rtlCol="0" anchor="ctr" wrap="square"/>
+          <a:lstStyle/>
+          <a:p>
+            <a:pPr algn="ctr"/>
+          </a:p>
+        </p:txBody>
+      </p:sp>
+      <p:sp>
+        <p:nvSpPr>
+          <p:cNvPr id="11" name="Oval 10"/>
+          <p:cNvSpPr/>
+          <p:nvPr/>
+        </p:nvSpPr>
+        <p:spPr>
+          <a:xfrm>
+            <a:off x="1447800" y="5016817"/>
+            <a:ext cx="97155" cy="97155"/>
+          </a:xfrm>
+          <a:prstGeom prst="ellipse">
+            <a:avLst/>
+          </a:prstGeom>
+          <a:solidFill>
+            <a:srgbClr val="0E7C86"/>
+          </a:solidFill>
+          <a:ln>
+            <a:noFill/>
+          </a:ln>
+          <a:effectLst/>
+        </p:spPr>
+        <p:txBody>
+          <a:bodyPr rtlCol="0" anchor="ctr" wrap="square"/>
+          <a:lstStyle/>
+          <a:p>
+            <a:pPr algn="ctr"/>
+          </a:p>
+        </p:txBody>
+      </p:sp>
+      <p:sp>
+        <p:nvSpPr>
+          <p:cNvPr id="12" name="TextBox 11"/>
+          <p:cNvSpPr txBox="1"/>
+          <p:nvPr/>
+        </p:nvSpPr>
+        <p:spPr>
+          <a:xfrm>
+            <a:off x="1633538" y="4838700"/>
+            <a:ext cx="6634162" cy="453390"/>
+          </a:xfrm>
+          <a:prstGeom prst="rect">
+            <a:avLst/>
+          </a:prstGeom>
+          <a:noFill/>
+        </p:spPr>
+        <p:txBody>
+          <a:bodyPr wrap="square" lIns="0" rIns="0" tIns="0" bIns="0" anchor="ctr">
+            <a:spAutoFit/>
+          </a:bodyPr>
+          <a:lstStyle/>
+          <a:p>
+            <a:pPr algn="l">
+              <a:lnSpc>
+                <a:spcPct val="120000"/>
+              </a:lnSpc>
+            </a:pPr>
+            <a:r>
+              <a:rPr sz="1575" b="0">
+                <a:solidFill>
+                  <a:srgbClr val="3D3D3D"/>
+                </a:solidFill>
+                <a:latin typeface="Pretendard"/>
+                <a:ea typeface="Pretendard"/>
+                <a:cs typeface="Pretendard"/>
+              </a:rPr>
+              <a:t>1·2단계: 업로드 후 OEE 요청</a:t>
+            </a:r>
+          </a:p>
+        </p:txBody>
+      </p:sp>
+      <p:sp>
+        <p:nvSpPr>
+          <p:cNvPr id="13" name="Oval 12"/>
+          <p:cNvSpPr/>
+          <p:nvPr/>
+        </p:nvSpPr>
+        <p:spPr>
+          <a:xfrm>
+            <a:off x="1447800" y="5527358"/>
+            <a:ext cx="97155" cy="97155"/>
+          </a:xfrm>
+          <a:prstGeom prst="ellipse">
+            <a:avLst/>
+          </a:prstGeom>
+          <a:solidFill>
+            <a:srgbClr val="0E7C86"/>
+          </a:solidFill>
+          <a:ln>
+            <a:noFill/>
+          </a:ln>
+          <a:effectLst/>
+        </p:spPr>
+        <p:txBody>
+          <a:bodyPr rtlCol="0" anchor="ctr" wrap="square"/>
+          <a:lstStyle/>
+          <a:p>
+            <a:pPr algn="ctr"/>
+          </a:p>
+        </p:txBody>
+      </p:sp>
+      <p:sp>
+        <p:nvSpPr>
+          <p:cNvPr id="14" name="TextBox 13"/>
+          <p:cNvSpPr txBox="1"/>
+          <p:nvPr/>
+        </p:nvSpPr>
+        <p:spPr>
+          <a:xfrm>
+            <a:off x="1633538" y="5349240"/>
+            <a:ext cx="6634162" cy="453390"/>
+          </a:xfrm>
+          <a:prstGeom prst="rect">
+            <a:avLst/>
+          </a:prstGeom>
+          <a:noFill/>
+        </p:spPr>
+        <p:txBody>
+          <a:bodyPr wrap="square" lIns="0" rIns="0" tIns="0" bIns="0" anchor="ctr">
+            <a:spAutoFit/>
+          </a:bodyPr>
+          <a:lstStyle/>
+          <a:p>
+            <a:pPr algn="l">
+              <a:lnSpc>
+                <a:spcPct val="120000"/>
+              </a:lnSpc>
+            </a:pPr>
+            <a:r>
+              <a:rPr sz="1575" b="0">
+                <a:solidFill>
+                  <a:srgbClr val="3D3D3D"/>
+                </a:solidFill>
+                <a:latin typeface="Pretendard"/>
+                <a:ea typeface="Pretendard"/>
+                <a:cs typeface="Pretendard"/>
+              </a:rPr>
+              <a:t>3·4단계: 피벗으로 다시 계산</a:t>
+            </a:r>
+          </a:p>
+        </p:txBody>
+      </p:sp>
+      <p:sp>
+        <p:nvSpPr>
+          <p:cNvPr id="15" name="Oval 14"/>
+          <p:cNvSpPr/>
+          <p:nvPr/>
+        </p:nvSpPr>
+        <p:spPr>
+          <a:xfrm>
+            <a:off x="1447800" y="6037898"/>
+            <a:ext cx="97155" cy="97155"/>
+          </a:xfrm>
+          <a:prstGeom prst="ellipse">
+            <a:avLst/>
+          </a:prstGeom>
+          <a:solidFill>
+            <a:srgbClr val="0E7C86"/>
+          </a:solidFill>
+          <a:ln>
+            <a:noFill/>
+          </a:ln>
+          <a:effectLst/>
+        </p:spPr>
+        <p:txBody>
+          <a:bodyPr rtlCol="0" anchor="ctr" wrap="square"/>
+          <a:lstStyle/>
+          <a:p>
+            <a:pPr algn="ctr"/>
+          </a:p>
+        </p:txBody>
+      </p:sp>
+      <p:sp>
+        <p:nvSpPr>
+          <p:cNvPr id="16" name="TextBox 15"/>
+          <p:cNvSpPr txBox="1"/>
+          <p:nvPr/>
+        </p:nvSpPr>
+        <p:spPr>
+          <a:xfrm>
+            <a:off x="1633538" y="5859780"/>
+            <a:ext cx="6634162" cy="453390"/>
+          </a:xfrm>
+          <a:prstGeom prst="rect">
+            <a:avLst/>
+          </a:prstGeom>
+          <a:noFill/>
+        </p:spPr>
+        <p:txBody>
+          <a:bodyPr wrap="square" lIns="0" rIns="0" tIns="0" bIns="0" anchor="ctr">
+            <a:spAutoFit/>
+          </a:bodyPr>
+          <a:lstStyle/>
+          <a:p>
+            <a:pPr algn="l">
+              <a:lnSpc>
+                <a:spcPct val="120000"/>
+              </a:lnSpc>
+            </a:pPr>
+            <a:r>
+              <a:rPr sz="1575" b="0">
+                <a:solidFill>
+                  <a:srgbClr val="3D3D3D"/>
+                </a:solidFill>
+                <a:latin typeface="Pretendard"/>
+                <a:ea typeface="Pretendard"/>
+                <a:cs typeface="Pretendard"/>
+              </a:rPr>
+              <a:t>5단계: 한 칸씩 대조</a:t>
+            </a:r>
+          </a:p>
+        </p:txBody>
+      </p:sp>
+      <p:sp>
+        <p:nvSpPr>
+          <p:cNvPr id="17" name="TextBox 16"/>
+          <p:cNvSpPr txBox="1"/>
+          <p:nvPr/>
+        </p:nvSpPr>
+        <p:spPr>
+          <a:xfrm>
+            <a:off x="9772650" y="2857500"/>
+            <a:ext cx="7372350" cy="533400"/>
+          </a:xfrm>
+          <a:prstGeom prst="rect">
+            <a:avLst/>
+          </a:prstGeom>
+          <a:noFill/>
+        </p:spPr>
+        <p:txBody>
+          <a:bodyPr wrap="square" lIns="0" rIns="0" tIns="0" bIns="0" anchor="t">
+            <a:spAutoFit/>
+          </a:bodyPr>
+          <a:lstStyle/>
+          <a:p>
+            <a:pPr algn="l">
+              <a:lnSpc>
+                <a:spcPct val="110000"/>
+              </a:lnSpc>
+            </a:pPr>
+            <a:r>
+              <a:rPr sz="3150" b="1">
+                <a:solidFill>
+                  <a:srgbClr val="0E2F4F"/>
+                </a:solidFill>
+                <a:latin typeface="Pretendard"/>
+                <a:ea typeface="Pretendard"/>
+                <a:cs typeface="Pretendard"/>
+              </a:rPr>
+              <a:t>무료 계정 · 한도</a:t>
+            </a:r>
+          </a:p>
+        </p:txBody>
+      </p:sp>
+      <p:sp>
+        <p:nvSpPr>
+          <p:cNvPr id="18" name="TextBox 17"/>
+          <p:cNvSpPr txBox="1"/>
+          <p:nvPr/>
+        </p:nvSpPr>
+        <p:spPr>
+          <a:xfrm>
+            <a:off x="9772650" y="3467100"/>
+            <a:ext cx="7372350" cy="876300"/>
+          </a:xfrm>
+          <a:prstGeom prst="rect">
+            <a:avLst/>
+          </a:prstGeom>
+          <a:noFill/>
+        </p:spPr>
+        <p:txBody>
+          <a:bodyPr wrap="square" lIns="0" rIns="0" tIns="0" bIns="0" anchor="t">
+            <a:spAutoFit/>
+          </a:bodyPr>
+          <a:lstStyle/>
+          <a:p>
+            <a:pPr algn="l">
+              <a:lnSpc>
+                <a:spcPct val="146000"/>
+              </a:lnSpc>
+            </a:pPr>
+            <a:r>
+              <a:rPr sz="2250" b="0">
+                <a:solidFill>
+                  <a:srgbClr val="3D3D3D"/>
+                </a:solidFill>
+                <a:latin typeface="Pretendard"/>
+                <a:ea typeface="Pretendard"/>
+                <a:cs typeface="Pretendard"/>
+              </a:rPr>
+              <a:t>Excel 먼저 → 합계표만 붙여 넣기</a:t>
+            </a:r>
+          </a:p>
+        </p:txBody>
+      </p:sp>
+      <p:sp>
+        <p:nvSpPr>
+          <p:cNvPr id="19" name="Rounded Rectangle 18"/>
+          <p:cNvSpPr/>
+          <p:nvPr/>
+        </p:nvSpPr>
+        <p:spPr>
+          <a:xfrm>
+            <a:off x="9772650" y="4610100"/>
+            <a:ext cx="7372350" cy="2857500"/>
+          </a:xfrm>
+          <a:prstGeom prst="roundRect">
+            <a:avLst>
+              <a:gd name="adj" fmla="val 1666"/>
+            </a:avLst>
+          </a:prstGeom>
+          <a:solidFill>
+            <a:srgbClr val="FAFBFD"/>
+          </a:solidFill>
+          <a:ln w="9525">
+            <a:solidFill>
+              <a:srgbClr val="DCE1E8"/>
+            </a:solidFill>
+          </a:ln>
+          <a:effectLst/>
+        </p:spPr>
+        <p:txBody>
+          <a:bodyPr rtlCol="0" anchor="ctr" wrap="square"/>
+          <a:lstStyle/>
+          <a:p>
+            <a:pPr algn="ctr"/>
+          </a:p>
+        </p:txBody>
+      </p:sp>
+      <p:sp>
+        <p:nvSpPr>
+          <p:cNvPr id="20" name="Oval 19"/>
+          <p:cNvSpPr/>
+          <p:nvPr/>
+        </p:nvSpPr>
+        <p:spPr>
+          <a:xfrm>
+            <a:off x="10077450" y="5016817"/>
+            <a:ext cx="97155" cy="97155"/>
+          </a:xfrm>
+          <a:prstGeom prst="ellipse">
+            <a:avLst/>
+          </a:prstGeom>
+          <a:solidFill>
+            <a:srgbClr val="0E7C86"/>
+          </a:solidFill>
+          <a:ln>
+            <a:noFill/>
+          </a:ln>
+          <a:effectLst/>
+        </p:spPr>
+        <p:txBody>
+          <a:bodyPr rtlCol="0" anchor="ctr" wrap="square"/>
+          <a:lstStyle/>
+          <a:p>
+            <a:pPr algn="ctr"/>
+          </a:p>
+        </p:txBody>
+      </p:sp>
+      <p:sp>
+        <p:nvSpPr>
+          <p:cNvPr id="21" name="TextBox 20"/>
+          <p:cNvSpPr txBox="1"/>
+          <p:nvPr/>
+        </p:nvSpPr>
+        <p:spPr>
+          <a:xfrm>
+            <a:off x="10263188" y="4838700"/>
+            <a:ext cx="6634162" cy="453390"/>
+          </a:xfrm>
+          <a:prstGeom prst="rect">
+            <a:avLst/>
+          </a:prstGeom>
+          <a:noFill/>
+        </p:spPr>
+        <p:txBody>
+          <a:bodyPr wrap="square" lIns="0" rIns="0" tIns="0" bIns="0" anchor="ctr">
+            <a:spAutoFit/>
+          </a:bodyPr>
+          <a:lstStyle/>
+          <a:p>
+            <a:pPr algn="l">
+              <a:lnSpc>
+                <a:spcPct val="120000"/>
+              </a:lnSpc>
+            </a:pPr>
+            <a:r>
+              <a:rPr sz="1575" b="0">
+                <a:solidFill>
+                  <a:srgbClr val="3D3D3D"/>
+                </a:solidFill>
+                <a:latin typeface="Pretendard"/>
+                <a:ea typeface="Pretendard"/>
+                <a:cs typeface="Pretendard"/>
+              </a:rPr>
+              <a:t>3·4단계 피벗을 먼저</a:t>
+            </a:r>
+          </a:p>
+        </p:txBody>
+      </p:sp>
+      <p:sp>
+        <p:nvSpPr>
+          <p:cNvPr id="22" name="Oval 21"/>
+          <p:cNvSpPr/>
+          <p:nvPr/>
+        </p:nvSpPr>
+        <p:spPr>
+          <a:xfrm>
+            <a:off x="10077450" y="5527358"/>
+            <a:ext cx="97155" cy="97155"/>
+          </a:xfrm>
+          <a:prstGeom prst="ellipse">
+            <a:avLst/>
+          </a:prstGeom>
+          <a:solidFill>
+            <a:srgbClr val="0E7C86"/>
+          </a:solidFill>
+          <a:ln>
+            <a:noFill/>
+          </a:ln>
+          <a:effectLst/>
+        </p:spPr>
+        <p:txBody>
+          <a:bodyPr rtlCol="0" anchor="ctr" wrap="square"/>
+          <a:lstStyle/>
+          <a:p>
+            <a:pPr algn="ctr"/>
+          </a:p>
+        </p:txBody>
+      </p:sp>
+      <p:sp>
+        <p:nvSpPr>
+          <p:cNvPr id="23" name="TextBox 22"/>
+          <p:cNvSpPr txBox="1"/>
+          <p:nvPr/>
+        </p:nvSpPr>
+        <p:spPr>
+          <a:xfrm>
+            <a:off x="10263188" y="5349240"/>
+            <a:ext cx="6634162" cy="453390"/>
+          </a:xfrm>
+          <a:prstGeom prst="rect">
+            <a:avLst/>
+          </a:prstGeom>
+          <a:noFill/>
+        </p:spPr>
+        <p:txBody>
+          <a:bodyPr wrap="square" lIns="0" rIns="0" tIns="0" bIns="0" anchor="ctr">
+            <a:spAutoFit/>
+          </a:bodyPr>
+          <a:lstStyle/>
+          <a:p>
+            <a:pPr algn="l">
+              <a:lnSpc>
+                <a:spcPct val="120000"/>
+              </a:lnSpc>
+            </a:pPr>
+            <a:r>
+              <a:rPr sz="1575" b="0">
+                <a:solidFill>
+                  <a:srgbClr val="3D3D3D"/>
+                </a:solidFill>
+                <a:latin typeface="Pretendard"/>
+                <a:ea typeface="Pretendard"/>
+                <a:cs typeface="Pretendard"/>
+              </a:rPr>
+              <a:t>공정별 합계 6행 복사·붙여넣기</a:t>
+            </a:r>
+          </a:p>
+        </p:txBody>
+      </p:sp>
+      <p:sp>
+        <p:nvSpPr>
+          <p:cNvPr id="24" name="Oval 23"/>
+          <p:cNvSpPr/>
+          <p:nvPr/>
+        </p:nvSpPr>
+        <p:spPr>
+          <a:xfrm>
+            <a:off x="10077450" y="6037898"/>
+            <a:ext cx="97155" cy="97155"/>
+          </a:xfrm>
+          <a:prstGeom prst="ellipse">
+            <a:avLst/>
+          </a:prstGeom>
+          <a:solidFill>
+            <a:srgbClr val="0E7C86"/>
+          </a:solidFill>
+          <a:ln>
+            <a:noFill/>
+          </a:ln>
+          <a:effectLst/>
+        </p:spPr>
+        <p:txBody>
+          <a:bodyPr rtlCol="0" anchor="ctr" wrap="square"/>
+          <a:lstStyle/>
+          <a:p>
+            <a:pPr algn="ctr"/>
+          </a:p>
+        </p:txBody>
+      </p:sp>
+      <p:sp>
+        <p:nvSpPr>
+          <p:cNvPr id="25" name="TextBox 24"/>
+          <p:cNvSpPr txBox="1"/>
+          <p:nvPr/>
+        </p:nvSpPr>
+        <p:spPr>
+          <a:xfrm>
+            <a:off x="10263188" y="5859780"/>
+            <a:ext cx="6634162" cy="453390"/>
+          </a:xfrm>
+          <a:prstGeom prst="rect">
+            <a:avLst/>
+          </a:prstGeom>
+          <a:noFill/>
+        </p:spPr>
+        <p:txBody>
+          <a:bodyPr wrap="square" lIns="0" rIns="0" tIns="0" bIns="0" anchor="ctr">
+            <a:spAutoFit/>
+          </a:bodyPr>
+          <a:lstStyle/>
+          <a:p>
+            <a:pPr algn="l">
+              <a:lnSpc>
+                <a:spcPct val="120000"/>
+              </a:lnSpc>
+            </a:pPr>
+            <a:r>
+              <a:rPr sz="1575" b="0">
+                <a:solidFill>
+                  <a:srgbClr val="3D3D3D"/>
+                </a:solidFill>
+                <a:latin typeface="Pretendard"/>
+                <a:ea typeface="Pretendard"/>
+                <a:cs typeface="Pretendard"/>
+              </a:rPr>
+              <a:t>「무료 계정이면」 프롬프트로 해석</a:t>
+            </a:r>
+          </a:p>
+        </p:txBody>
+      </p:sp>
+      <p:sp>
+        <p:nvSpPr>
+          <p:cNvPr id="26" name="Oval 25"/>
+          <p:cNvSpPr/>
+          <p:nvPr/>
+        </p:nvSpPr>
+        <p:spPr>
+          <a:xfrm>
+            <a:off x="8686800" y="3771900"/>
+            <a:ext cx="914400" cy="914400"/>
+          </a:xfrm>
+          <a:prstGeom prst="ellipse">
+            <a:avLst/>
+          </a:prstGeom>
+          <a:solidFill>
+            <a:srgbClr val="0E2F4F"/>
+          </a:solidFill>
+          <a:ln>
+            <a:noFill/>
+          </a:ln>
+          <a:effectLst/>
+        </p:spPr>
+        <p:txBody>
+          <a:bodyPr rtlCol="0" anchor="ctr" wrap="square"/>
+          <a:lstStyle/>
+          <a:p>
+            <a:pPr algn="ctr"/>
+          </a:p>
+        </p:txBody>
+      </p:sp>
+      <p:sp>
+        <p:nvSpPr>
+          <p:cNvPr id="27" name="TextBox 26"/>
+          <p:cNvSpPr txBox="1"/>
+          <p:nvPr/>
+        </p:nvSpPr>
+        <p:spPr>
+          <a:xfrm>
+            <a:off x="8686800" y="4057650"/>
+            <a:ext cx="914400" cy="381000"/>
+          </a:xfrm>
+          <a:prstGeom prst="rect">
+            <a:avLst/>
+          </a:prstGeom>
+          <a:noFill/>
+        </p:spPr>
+        <p:txBody>
+          <a:bodyPr wrap="square" lIns="0" rIns="0" tIns="0" bIns="0" anchor="t">
+            <a:spAutoFit/>
+          </a:bodyPr>
+          <a:lstStyle/>
+          <a:p>
+            <a:pPr algn="ctr">
+              <a:lnSpc>
+                <a:spcPct val="100000"/>
+              </a:lnSpc>
+            </a:pPr>
+            <a:r>
+              <a:rPr sz="2250" b="1">
+                <a:solidFill>
+                  <a:srgbClr val="FFFFFF"/>
+                </a:solidFill>
+                <a:latin typeface="Pretendard"/>
+                <a:ea typeface="Pretendard"/>
+                <a:cs typeface="Pretendard"/>
+              </a:rPr>
+              <a:t>VS</a:t>
+            </a:r>
+          </a:p>
+        </p:txBody>
+      </p:sp>
+      <p:sp>
+        <p:nvSpPr>
+          <p:cNvPr id="28" name="Rectangle 27"/>
+          <p:cNvSpPr/>
+          <p:nvPr/>
+        </p:nvSpPr>
+        <p:spPr>
+          <a:xfrm>
+            <a:off x="1143000" y="8058150"/>
+            <a:ext cx="16002000" cy="9525"/>
+          </a:xfrm>
+          <a:prstGeom prst="rect">
+            <a:avLst/>
+          </a:prstGeom>
+          <a:solidFill>
+            <a:srgbClr val="DCE1E8"/>
+          </a:solidFill>
+          <a:ln>
+            <a:noFill/>
+          </a:ln>
+          <a:effectLst/>
+        </p:spPr>
+        <p:txBody>
+          <a:bodyPr rtlCol="0" anchor="ctr" wrap="square"/>
+          <a:lstStyle/>
+          <a:p>
+            <a:pPr algn="ctr"/>
+          </a:p>
+        </p:txBody>
+      </p:sp>
+      <p:sp>
+        <p:nvSpPr>
+          <p:cNvPr id="29" name="TextBox 28"/>
+          <p:cNvSpPr txBox="1"/>
+          <p:nvPr/>
+        </p:nvSpPr>
+        <p:spPr>
+          <a:xfrm>
+            <a:off x="1143000" y="8248650"/>
+            <a:ext cx="13335000" cy="323850"/>
+          </a:xfrm>
+          <a:prstGeom prst="rect">
+            <a:avLst/>
+          </a:prstGeom>
+          <a:noFill/>
+        </p:spPr>
+        <p:txBody>
+          <a:bodyPr wrap="square" lIns="0" rIns="0" tIns="0" bIns="0" anchor="t">
+            <a:spAutoFit/>
+          </a:bodyPr>
+          <a:lstStyle/>
+          <a:p>
+            <a:pPr algn="l">
+              <a:lnSpc>
+                <a:spcPct val="100000"/>
+              </a:lnSpc>
+            </a:pPr>
+            <a:r>
+              <a:rPr sz="1725" b="0">
+                <a:solidFill>
+                  <a:srgbClr val="7D7D7D"/>
+                </a:solidFill>
+                <a:latin typeface="Pretendard"/>
+                <a:ea typeface="Pretendard"/>
+                <a:cs typeface="Pretendard"/>
+              </a:rPr>
+              <a:t>생성형 AI 활용 실무 · 4일 32H · 2일차 3교시 · 실습</a:t>
+            </a:r>
+          </a:p>
+        </p:txBody>
+      </p:sp>
+      <p:sp>
+        <p:nvSpPr>
+          <p:cNvPr id="30" name="TextBox 29"/>
+          <p:cNvSpPr txBox="1"/>
+          <p:nvPr/>
+        </p:nvSpPr>
+        <p:spPr>
+          <a:xfrm>
+            <a:off x="15240000" y="8248650"/>
+            <a:ext cx="1905000" cy="323850"/>
+          </a:xfrm>
+          <a:prstGeom prst="rect">
+            <a:avLst/>
+          </a:prstGeom>
+          <a:noFill/>
+        </p:spPr>
+        <p:txBody>
+          <a:bodyPr wrap="square" lIns="0" rIns="0" tIns="0" bIns="0" anchor="t">
+            <a:spAutoFit/>
+          </a:bodyPr>
+          <a:lstStyle/>
+          <a:p>
+            <a:pPr algn="r">
+              <a:lnSpc>
+                <a:spcPct val="100000"/>
+              </a:lnSpc>
+            </a:pPr>
+            <a:r>
+              <a:rPr sz="1725" b="0">
+                <a:solidFill>
+                  <a:srgbClr val="7D7D7D"/>
+                </a:solidFill>
+                <a:latin typeface="Pretendard"/>
+                <a:ea typeface="Pretendard"/>
+                <a:cs typeface="Pretendard"/>
+              </a:rPr>
+              <a:t>11</a:t>
+            </a:r>
+          </a:p>
+        </p:txBody>
+      </p:sp>
+    </p:spTree>
+  </p:cSld>
+  <p:clrMapOvr>
+    <a:masterClrMapping/>
+  </p:clrMapOvr>
+</p:sld>
+</file>
+
+<file path=ppt/slides/slide12.xml><?xml version="1.0" encoding="utf-8"?>
 <p:sld xmlns:a="http://schemas.openxmlformats.org/drawingml/2006/main" xmlns:p="http://schemas.openxmlformats.org/presentationml/2006/main" xmlns:r="http://schemas.openxmlformats.org/officeDocument/2006/relationships">
   <p:cSld>
     <p:spTree>

</xml_diff>